<commit_message>
docs: update reward modeling and sft materials
</commit_message>
<xml_diff>
--- a/LLM/阶段一.pptx
+++ b/LLM/阶段一.pptx
@@ -5,7 +5,7 @@
     <p:sldMasterId id="2147483648" r:id="rId1"/>
   </p:sldMasterIdLst>
   <p:notesMasterIdLst>
-    <p:notesMasterId r:id="rId15"/>
+    <p:notesMasterId r:id="rId17"/>
   </p:notesMasterIdLst>
   <p:sldIdLst>
     <p:sldId id="256" r:id="rId2"/>
@@ -21,6 +21,8 @@
     <p:sldId id="271" r:id="rId12"/>
     <p:sldId id="272" r:id="rId13"/>
     <p:sldId id="278" r:id="rId14"/>
+    <p:sldId id="279" r:id="rId15"/>
+    <p:sldId id="280" r:id="rId16"/>
   </p:sldIdLst>
   <p:sldSz cx="12192000" cy="6858000"/>
   <p:notesSz cx="6858000" cy="9144000"/>
@@ -138,6 +140,42 @@
 </p:presentation>
 </file>
 
+<file path=ppt/authors.xml><?xml version="1.0" encoding="utf-8"?>
+<p188:authorLst xmlns:a="http://schemas.openxmlformats.org/drawingml/2006/main" xmlns:r="http://schemas.openxmlformats.org/officeDocument/2006/relationships" xmlns:p188="http://schemas.microsoft.com/office/powerpoint/2018/8/main">
+  <p188:author id="{0885DA48-52E3-A539-821A-31189D645E1D}" name="祈 楪" initials="祈楪" userId="014d52ee20da7d07" providerId="Windows Live"/>
+</p188:authorLst>
+</file>
+
+<file path=ppt/comments/modernComment_117_B4C71992.xml><?xml version="1.0" encoding="utf-8"?>
+<p188:cmLst xmlns:a="http://schemas.openxmlformats.org/drawingml/2006/main" xmlns:r="http://schemas.openxmlformats.org/officeDocument/2006/relationships" xmlns:p188="http://schemas.microsoft.com/office/powerpoint/2018/8/main">
+  <p188:cm id="{61557C65-BBA1-4CE3-8B18-EF6179EB17E1}" authorId="{0885DA48-52E3-A539-821A-31189D645E1D}" created="2026-05-02T11:13:02.446">
+    <ac:txMkLst xmlns:ac="http://schemas.microsoft.com/office/drawing/2013/main/command">
+      <pc:docMk xmlns:pc="http://schemas.microsoft.com/office/powerpoint/2013/main/command"/>
+      <pc:sldMk xmlns:pc="http://schemas.microsoft.com/office/powerpoint/2013/main/command" cId="3032947090" sldId="279"/>
+      <ac:spMk id="5" creationId="{5AEE5B00-17B5-6CAA-9D22-2A9D23FD8934}"/>
+      <ac:txMk cp="0" len="79">
+        <ac:context len="80" hash="2526429526"/>
+      </ac:txMk>
+    </ac:txMkLst>
+    <p188:pos x="12125124" y="194467"/>
+    <p188:txBody>
+      <a:bodyPr/>
+      <a:lstStyle/>
+      <a:p>
+        <a:r>
+          <a:rPr lang="zh-CN" altLang="en-US"/>
+          <a:t>SPARK 的核心思想：
+1.用生成模型产生多种解答。
+2.用 verifier 通过 self-consistency 和 meta-critique 生成合成验证信号。
+3.用合成数据训练一个 generative process reward model。
+4.在 RL 中用这个 PRM 给模型每一步的奖励</a:t>
+        </a:r>
+      </a:p>
+    </p188:txBody>
+  </p188:cm>
+</p188:cmLst>
+</file>
+
 <file path=ppt/notesMasters/notesMaster1.xml><?xml version="1.0" encoding="utf-8"?>
 <p:notesMaster xmlns:a="http://schemas.openxmlformats.org/drawingml/2006/main" xmlns:r="http://schemas.openxmlformats.org/officeDocument/2006/relationships" xmlns:p="http://schemas.openxmlformats.org/presentationml/2006/main">
   <p:cSld>
@@ -220,7 +258,7 @@
           <a:p>
             <a:fld id="{B9E7821D-D706-4DD4-95CE-52CCF92123E0}" type="datetimeFigureOut">
               <a:rPr lang="zh-CN" altLang="en-US" smtClean="0"/>
-              <a:t>2026/4/29</a:t>
+              <a:t>2026/5/2</a:t>
             </a:fld>
             <a:endParaRPr lang="zh-CN" altLang="en-US"/>
           </a:p>
@@ -578,6 +616,121 @@
 </p:notes>
 </file>
 
+<file path=ppt/notesSlides/notesSlide10.xml><?xml version="1.0" encoding="utf-8"?>
+<p:notes xmlns:a="http://schemas.openxmlformats.org/drawingml/2006/main" xmlns:r="http://schemas.openxmlformats.org/officeDocument/2006/relationships" xmlns:p="http://schemas.openxmlformats.org/presentationml/2006/main">
+  <p:cSld>
+    <p:spTree>
+      <p:nvGrpSpPr>
+        <p:cNvPr id="1" name="">
+          <a:extLst>
+            <a:ext uri="{FF2B5EF4-FFF2-40B4-BE49-F238E27FC236}">
+              <a16:creationId xmlns:a16="http://schemas.microsoft.com/office/drawing/2014/main" id="{95544447-C083-4F3B-DC3C-76799E4D1E84}"/>
+            </a:ext>
+          </a:extLst>
+        </p:cNvPr>
+        <p:cNvGrpSpPr/>
+        <p:nvPr/>
+      </p:nvGrpSpPr>
+      <p:grpSpPr>
+        <a:xfrm>
+          <a:off x="0" y="0"/>
+          <a:ext cx="0" cy="0"/>
+          <a:chOff x="0" y="0"/>
+          <a:chExt cx="0" cy="0"/>
+        </a:xfrm>
+      </p:grpSpPr>
+      <p:sp>
+        <p:nvSpPr>
+          <p:cNvPr id="2" name="幻灯片图像占位符 1">
+            <a:extLst>
+              <a:ext uri="{FF2B5EF4-FFF2-40B4-BE49-F238E27FC236}">
+                <a16:creationId xmlns:a16="http://schemas.microsoft.com/office/drawing/2014/main" id="{BA74C36B-F87C-530D-62B7-2766AF880133}"/>
+              </a:ext>
+            </a:extLst>
+          </p:cNvPr>
+          <p:cNvSpPr>
+            <a:spLocks noGrp="1" noRot="1" noChangeAspect="1"/>
+          </p:cNvSpPr>
+          <p:nvPr>
+            <p:ph type="sldImg"/>
+          </p:nvPr>
+        </p:nvSpPr>
+        <p:spPr/>
+        <p:txBody>
+          <a:bodyPr/>
+          <a:lstStyle/>
+          <a:p>
+            <a:endParaRPr lang="zh-CN" altLang="en-US"/>
+          </a:p>
+        </p:txBody>
+      </p:sp>
+      <p:sp>
+        <p:nvSpPr>
+          <p:cNvPr id="3" name="备注占位符 2">
+            <a:extLst>
+              <a:ext uri="{FF2B5EF4-FFF2-40B4-BE49-F238E27FC236}">
+                <a16:creationId xmlns:a16="http://schemas.microsoft.com/office/drawing/2014/main" id="{35CE85FE-FE0E-FA57-E052-0A91D541E9A7}"/>
+              </a:ext>
+            </a:extLst>
+          </p:cNvPr>
+          <p:cNvSpPr>
+            <a:spLocks noGrp="1"/>
+          </p:cNvSpPr>
+          <p:nvPr>
+            <p:ph type="body" idx="1"/>
+          </p:nvPr>
+        </p:nvSpPr>
+        <p:spPr/>
+        <p:txBody>
+          <a:bodyPr/>
+          <a:lstStyle/>
+          <a:p>
+            <a:endParaRPr lang="zh-CN" altLang="en-US" dirty="0"/>
+          </a:p>
+        </p:txBody>
+      </p:sp>
+      <p:sp>
+        <p:nvSpPr>
+          <p:cNvPr id="4" name="灯片编号占位符 3">
+            <a:extLst>
+              <a:ext uri="{FF2B5EF4-FFF2-40B4-BE49-F238E27FC236}">
+                <a16:creationId xmlns:a16="http://schemas.microsoft.com/office/drawing/2014/main" id="{DD3A92DD-C230-A3D7-88E3-60BAF8DCC453}"/>
+              </a:ext>
+            </a:extLst>
+          </p:cNvPr>
+          <p:cNvSpPr>
+            <a:spLocks noGrp="1"/>
+          </p:cNvSpPr>
+          <p:nvPr>
+            <p:ph type="sldNum" sz="quarter" idx="5"/>
+          </p:nvPr>
+        </p:nvSpPr>
+        <p:spPr/>
+        <p:txBody>
+          <a:bodyPr/>
+          <a:lstStyle/>
+          <a:p>
+            <a:fld id="{C1392EEC-5A43-47B9-BD96-D1C08A9714A4}" type="slidenum">
+              <a:rPr lang="zh-CN" altLang="en-US" smtClean="0"/>
+              <a:t>15</a:t>
+            </a:fld>
+            <a:endParaRPr lang="zh-CN" altLang="en-US"/>
+          </a:p>
+        </p:txBody>
+      </p:sp>
+    </p:spTree>
+    <p:extLst>
+      <p:ext uri="{BB962C8B-B14F-4D97-AF65-F5344CB8AC3E}">
+        <p14:creationId xmlns:p14="http://schemas.microsoft.com/office/powerpoint/2010/main" val="2235542797"/>
+      </p:ext>
+    </p:extLst>
+  </p:cSld>
+  <p:clrMapOvr>
+    <a:masterClrMapping/>
+  </p:clrMapOvr>
+</p:notes>
+</file>
+
 <file path=ppt/notesSlides/notesSlide2.xml><?xml version="1.0" encoding="utf-8"?>
 <p:notes xmlns:a="http://schemas.openxmlformats.org/drawingml/2006/main" xmlns:r="http://schemas.openxmlformats.org/officeDocument/2006/relationships" xmlns:p="http://schemas.openxmlformats.org/presentationml/2006/main">
   <p:cSld>
@@ -1350,6 +1503,121 @@
     <p:extLst>
       <p:ext uri="{BB962C8B-B14F-4D97-AF65-F5344CB8AC3E}">
         <p14:creationId xmlns:p14="http://schemas.microsoft.com/office/powerpoint/2010/main" val="2026231553"/>
+      </p:ext>
+    </p:extLst>
+  </p:cSld>
+  <p:clrMapOvr>
+    <a:masterClrMapping/>
+  </p:clrMapOvr>
+</p:notes>
+</file>
+
+<file path=ppt/notesSlides/notesSlide9.xml><?xml version="1.0" encoding="utf-8"?>
+<p:notes xmlns:a="http://schemas.openxmlformats.org/drawingml/2006/main" xmlns:r="http://schemas.openxmlformats.org/officeDocument/2006/relationships" xmlns:p="http://schemas.openxmlformats.org/presentationml/2006/main">
+  <p:cSld>
+    <p:spTree>
+      <p:nvGrpSpPr>
+        <p:cNvPr id="1" name="">
+          <a:extLst>
+            <a:ext uri="{FF2B5EF4-FFF2-40B4-BE49-F238E27FC236}">
+              <a16:creationId xmlns:a16="http://schemas.microsoft.com/office/drawing/2014/main" id="{DB055E2C-5105-54E7-CCFF-45ADC18009F0}"/>
+            </a:ext>
+          </a:extLst>
+        </p:cNvPr>
+        <p:cNvGrpSpPr/>
+        <p:nvPr/>
+      </p:nvGrpSpPr>
+      <p:grpSpPr>
+        <a:xfrm>
+          <a:off x="0" y="0"/>
+          <a:ext cx="0" cy="0"/>
+          <a:chOff x="0" y="0"/>
+          <a:chExt cx="0" cy="0"/>
+        </a:xfrm>
+      </p:grpSpPr>
+      <p:sp>
+        <p:nvSpPr>
+          <p:cNvPr id="2" name="幻灯片图像占位符 1">
+            <a:extLst>
+              <a:ext uri="{FF2B5EF4-FFF2-40B4-BE49-F238E27FC236}">
+                <a16:creationId xmlns:a16="http://schemas.microsoft.com/office/drawing/2014/main" id="{FC5AA6A6-7615-EEFA-B6AB-F357D44BAC74}"/>
+              </a:ext>
+            </a:extLst>
+          </p:cNvPr>
+          <p:cNvSpPr>
+            <a:spLocks noGrp="1" noRot="1" noChangeAspect="1"/>
+          </p:cNvSpPr>
+          <p:nvPr>
+            <p:ph type="sldImg"/>
+          </p:nvPr>
+        </p:nvSpPr>
+        <p:spPr/>
+        <p:txBody>
+          <a:bodyPr/>
+          <a:lstStyle/>
+          <a:p>
+            <a:endParaRPr lang="zh-CN" altLang="en-US"/>
+          </a:p>
+        </p:txBody>
+      </p:sp>
+      <p:sp>
+        <p:nvSpPr>
+          <p:cNvPr id="3" name="备注占位符 2">
+            <a:extLst>
+              <a:ext uri="{FF2B5EF4-FFF2-40B4-BE49-F238E27FC236}">
+                <a16:creationId xmlns:a16="http://schemas.microsoft.com/office/drawing/2014/main" id="{8E08A608-918A-4561-9CEE-AA6B6BA3E55D}"/>
+              </a:ext>
+            </a:extLst>
+          </p:cNvPr>
+          <p:cNvSpPr>
+            <a:spLocks noGrp="1"/>
+          </p:cNvSpPr>
+          <p:nvPr>
+            <p:ph type="body" idx="1"/>
+          </p:nvPr>
+        </p:nvSpPr>
+        <p:spPr/>
+        <p:txBody>
+          <a:bodyPr/>
+          <a:lstStyle/>
+          <a:p>
+            <a:endParaRPr lang="zh-CN" altLang="en-US" dirty="0"/>
+          </a:p>
+        </p:txBody>
+      </p:sp>
+      <p:sp>
+        <p:nvSpPr>
+          <p:cNvPr id="4" name="灯片编号占位符 3">
+            <a:extLst>
+              <a:ext uri="{FF2B5EF4-FFF2-40B4-BE49-F238E27FC236}">
+                <a16:creationId xmlns:a16="http://schemas.microsoft.com/office/drawing/2014/main" id="{F2F29AC8-DAB2-E858-2CF1-4E071833C4A6}"/>
+              </a:ext>
+            </a:extLst>
+          </p:cNvPr>
+          <p:cNvSpPr>
+            <a:spLocks noGrp="1"/>
+          </p:cNvSpPr>
+          <p:nvPr>
+            <p:ph type="sldNum" sz="quarter" idx="5"/>
+          </p:nvPr>
+        </p:nvSpPr>
+        <p:spPr/>
+        <p:txBody>
+          <a:bodyPr/>
+          <a:lstStyle/>
+          <a:p>
+            <a:fld id="{C1392EEC-5A43-47B9-BD96-D1C08A9714A4}" type="slidenum">
+              <a:rPr lang="zh-CN" altLang="en-US" smtClean="0"/>
+              <a:t>14</a:t>
+            </a:fld>
+            <a:endParaRPr lang="zh-CN" altLang="en-US"/>
+          </a:p>
+        </p:txBody>
+      </p:sp>
+    </p:spTree>
+    <p:extLst>
+      <p:ext uri="{BB962C8B-B14F-4D97-AF65-F5344CB8AC3E}">
+        <p14:creationId xmlns:p14="http://schemas.microsoft.com/office/powerpoint/2010/main" val="3284596318"/>
       </p:ext>
     </p:extLst>
   </p:cSld>
@@ -1506,7 +1774,7 @@
           <a:p>
             <a:fld id="{CC37D159-D846-43FD-8AE1-DC0896E64EB2}" type="datetimeFigureOut">
               <a:rPr lang="zh-CN" altLang="en-US" smtClean="0"/>
-              <a:t>2026/4/29</a:t>
+              <a:t>2026/5/2</a:t>
             </a:fld>
             <a:endParaRPr lang="zh-CN" altLang="en-US"/>
           </a:p>
@@ -1704,7 +1972,7 @@
           <a:p>
             <a:fld id="{CC37D159-D846-43FD-8AE1-DC0896E64EB2}" type="datetimeFigureOut">
               <a:rPr lang="zh-CN" altLang="en-US" smtClean="0"/>
-              <a:t>2026/4/29</a:t>
+              <a:t>2026/5/2</a:t>
             </a:fld>
             <a:endParaRPr lang="zh-CN" altLang="en-US"/>
           </a:p>
@@ -1912,7 +2180,7 @@
           <a:p>
             <a:fld id="{CC37D159-D846-43FD-8AE1-DC0896E64EB2}" type="datetimeFigureOut">
               <a:rPr lang="zh-CN" altLang="en-US" smtClean="0"/>
-              <a:t>2026/4/29</a:t>
+              <a:t>2026/5/2</a:t>
             </a:fld>
             <a:endParaRPr lang="zh-CN" altLang="en-US"/>
           </a:p>
@@ -2110,7 +2378,7 @@
           <a:p>
             <a:fld id="{CC37D159-D846-43FD-8AE1-DC0896E64EB2}" type="datetimeFigureOut">
               <a:rPr lang="zh-CN" altLang="en-US" smtClean="0"/>
-              <a:t>2026/4/29</a:t>
+              <a:t>2026/5/2</a:t>
             </a:fld>
             <a:endParaRPr lang="zh-CN" altLang="en-US"/>
           </a:p>
@@ -2385,7 +2653,7 @@
           <a:p>
             <a:fld id="{CC37D159-D846-43FD-8AE1-DC0896E64EB2}" type="datetimeFigureOut">
               <a:rPr lang="zh-CN" altLang="en-US" smtClean="0"/>
-              <a:t>2026/4/29</a:t>
+              <a:t>2026/5/2</a:t>
             </a:fld>
             <a:endParaRPr lang="zh-CN" altLang="en-US"/>
           </a:p>
@@ -2650,7 +2918,7 @@
           <a:p>
             <a:fld id="{CC37D159-D846-43FD-8AE1-DC0896E64EB2}" type="datetimeFigureOut">
               <a:rPr lang="zh-CN" altLang="en-US" smtClean="0"/>
-              <a:t>2026/4/29</a:t>
+              <a:t>2026/5/2</a:t>
             </a:fld>
             <a:endParaRPr lang="zh-CN" altLang="en-US"/>
           </a:p>
@@ -3062,7 +3330,7 @@
           <a:p>
             <a:fld id="{CC37D159-D846-43FD-8AE1-DC0896E64EB2}" type="datetimeFigureOut">
               <a:rPr lang="zh-CN" altLang="en-US" smtClean="0"/>
-              <a:t>2026/4/29</a:t>
+              <a:t>2026/5/2</a:t>
             </a:fld>
             <a:endParaRPr lang="zh-CN" altLang="en-US"/>
           </a:p>
@@ -3203,7 +3471,7 @@
           <a:p>
             <a:fld id="{CC37D159-D846-43FD-8AE1-DC0896E64EB2}" type="datetimeFigureOut">
               <a:rPr lang="zh-CN" altLang="en-US" smtClean="0"/>
-              <a:t>2026/4/29</a:t>
+              <a:t>2026/5/2</a:t>
             </a:fld>
             <a:endParaRPr lang="zh-CN" altLang="en-US"/>
           </a:p>
@@ -3316,7 +3584,7 @@
           <a:p>
             <a:fld id="{CC37D159-D846-43FD-8AE1-DC0896E64EB2}" type="datetimeFigureOut">
               <a:rPr lang="zh-CN" altLang="en-US" smtClean="0"/>
-              <a:t>2026/4/29</a:t>
+              <a:t>2026/5/2</a:t>
             </a:fld>
             <a:endParaRPr lang="zh-CN" altLang="en-US"/>
           </a:p>
@@ -3627,7 +3895,7 @@
           <a:p>
             <a:fld id="{CC37D159-D846-43FD-8AE1-DC0896E64EB2}" type="datetimeFigureOut">
               <a:rPr lang="zh-CN" altLang="en-US" smtClean="0"/>
-              <a:t>2026/4/29</a:t>
+              <a:t>2026/5/2</a:t>
             </a:fld>
             <a:endParaRPr lang="zh-CN" altLang="en-US"/>
           </a:p>
@@ -3915,7 +4183,7 @@
           <a:p>
             <a:fld id="{CC37D159-D846-43FD-8AE1-DC0896E64EB2}" type="datetimeFigureOut">
               <a:rPr lang="zh-CN" altLang="en-US" smtClean="0"/>
-              <a:t>2026/4/29</a:t>
+              <a:t>2026/5/2</a:t>
             </a:fld>
             <a:endParaRPr lang="zh-CN" altLang="en-US"/>
           </a:p>
@@ -4156,7 +4424,7 @@
           <a:p>
             <a:fld id="{CC37D159-D846-43FD-8AE1-DC0896E64EB2}" type="datetimeFigureOut">
               <a:rPr lang="zh-CN" altLang="en-US" smtClean="0"/>
-              <a:t>2026/4/29</a:t>
+              <a:t>2026/5/2</a:t>
             </a:fld>
             <a:endParaRPr lang="zh-CN" altLang="en-US"/>
           </a:p>
@@ -6965,6 +7233,714 @@
 </p:sld>
 </file>
 
+<file path=ppt/slides/slide14.xml><?xml version="1.0" encoding="utf-8"?>
+<p:sld xmlns:a="http://schemas.openxmlformats.org/drawingml/2006/main" xmlns:r="http://schemas.openxmlformats.org/officeDocument/2006/relationships" xmlns:p="http://schemas.openxmlformats.org/presentationml/2006/main">
+  <p:cSld>
+    <p:spTree>
+      <p:nvGrpSpPr>
+        <p:cNvPr id="1" name="">
+          <a:extLst>
+            <a:ext uri="{FF2B5EF4-FFF2-40B4-BE49-F238E27FC236}">
+              <a16:creationId xmlns:a16="http://schemas.microsoft.com/office/drawing/2014/main" id="{0FEB5A8A-6FD2-89CD-66FC-3FEA15B3A170}"/>
+            </a:ext>
+          </a:extLst>
+        </p:cNvPr>
+        <p:cNvGrpSpPr/>
+        <p:nvPr/>
+      </p:nvGrpSpPr>
+      <p:grpSpPr>
+        <a:xfrm>
+          <a:off x="0" y="0"/>
+          <a:ext cx="0" cy="0"/>
+          <a:chOff x="0" y="0"/>
+          <a:chExt cx="0" cy="0"/>
+        </a:xfrm>
+      </p:grpSpPr>
+      <p:sp>
+        <p:nvSpPr>
+          <p:cNvPr id="5" name="矩形 4">
+            <a:extLst>
+              <a:ext uri="{FF2B5EF4-FFF2-40B4-BE49-F238E27FC236}">
+                <a16:creationId xmlns:a16="http://schemas.microsoft.com/office/drawing/2014/main" id="{5AEE5B00-17B5-6CAA-9D22-2A9D23FD8934}"/>
+              </a:ext>
+            </a:extLst>
+          </p:cNvPr>
+          <p:cNvSpPr/>
+          <p:nvPr/>
+        </p:nvSpPr>
+        <p:spPr>
+          <a:xfrm>
+            <a:off x="19251" y="205583"/>
+            <a:ext cx="12172749" cy="651933"/>
+          </a:xfrm>
+          <a:prstGeom prst="rect">
+            <a:avLst/>
+          </a:prstGeom>
+          <a:solidFill>
+            <a:schemeClr val="bg1"/>
+          </a:solidFill>
+          <a:ln>
+            <a:solidFill>
+              <a:schemeClr val="bg1"/>
+            </a:solidFill>
+          </a:ln>
+        </p:spPr>
+        <p:style>
+          <a:lnRef idx="2">
+            <a:schemeClr val="accent1">
+              <a:shade val="15000"/>
+            </a:schemeClr>
+          </a:lnRef>
+          <a:fillRef idx="1">
+            <a:schemeClr val="accent1"/>
+          </a:fillRef>
+          <a:effectRef idx="0">
+            <a:schemeClr val="accent1"/>
+          </a:effectRef>
+          <a:fontRef idx="minor">
+            <a:schemeClr val="lt1"/>
+          </a:fontRef>
+        </p:style>
+        <p:txBody>
+          <a:bodyPr rtlCol="0" anchor="ctr"/>
+          <a:lstStyle/>
+          <a:p>
+            <a:pPr algn="just" latinLnBrk="1"/>
+            <a:r>
+              <a:rPr lang="en-US" altLang="zh-CN" sz="3000" dirty="0">
+                <a:solidFill>
+                  <a:schemeClr val="tx1"/>
+                </a:solidFill>
+                <a:latin typeface="Times New Roman" panose="02020603050405020304" pitchFamily="18" charset="0"/>
+                <a:cs typeface="Times New Roman" panose="02020603050405020304" pitchFamily="18" charset="0"/>
+              </a:rPr>
+              <a:t>SPARK: STEPWISE PROCESS-AWARE REWARDS FOR REFERENCE-FREE REINFORCEMENT LEARNING</a:t>
+            </a:r>
+          </a:p>
+        </p:txBody>
+      </p:sp>
+      <p:sp>
+        <p:nvSpPr>
+          <p:cNvPr id="7" name="文本框 6">
+            <a:extLst>
+              <a:ext uri="{FF2B5EF4-FFF2-40B4-BE49-F238E27FC236}">
+                <a16:creationId xmlns:a16="http://schemas.microsoft.com/office/drawing/2014/main" id="{37050EC8-88B9-F005-EB4F-30C64FD45601}"/>
+              </a:ext>
+            </a:extLst>
+          </p:cNvPr>
+          <p:cNvSpPr txBox="1"/>
+          <p:nvPr/>
+        </p:nvSpPr>
+        <p:spPr>
+          <a:xfrm>
+            <a:off x="129208" y="2150816"/>
+            <a:ext cx="12192000" cy="3416320"/>
+          </a:xfrm>
+          <a:prstGeom prst="rect">
+            <a:avLst/>
+          </a:prstGeom>
+          <a:noFill/>
+        </p:spPr>
+        <p:txBody>
+          <a:bodyPr wrap="square" rtlCol="0">
+            <a:spAutoFit/>
+          </a:bodyPr>
+          <a:lstStyle/>
+          <a:p>
+            <a:r>
+              <a:rPr lang="zh-CN" altLang="en-US" sz="2400" dirty="0">
+                <a:latin typeface="Times New Roman" panose="02020603050405020304" pitchFamily="18" charset="0"/>
+                <a:ea typeface="SimSun" panose="02010600030101010101" pitchFamily="2" charset="-122"/>
+                <a:cs typeface="Times New Roman" panose="02020603050405020304" pitchFamily="18" charset="0"/>
+              </a:rPr>
+              <a:t>问题：当前 </a:t>
+            </a:r>
+            <a:r>
+              <a:rPr lang="de-DE" altLang="zh-CN" sz="2400" dirty="0">
+                <a:latin typeface="Times New Roman" panose="02020603050405020304" pitchFamily="18" charset="0"/>
+                <a:ea typeface="SimSun" panose="02010600030101010101" pitchFamily="2" charset="-122"/>
+                <a:cs typeface="Times New Roman" panose="02020603050405020304" pitchFamily="18" charset="0"/>
+              </a:rPr>
+              <a:t>RLVR </a:t>
+            </a:r>
+            <a:r>
+              <a:rPr lang="zh-CN" altLang="en-US" sz="2400" dirty="0">
+                <a:latin typeface="Times New Roman" panose="02020603050405020304" pitchFamily="18" charset="0"/>
+                <a:ea typeface="SimSun" panose="02010600030101010101" pitchFamily="2" charset="-122"/>
+                <a:cs typeface="Times New Roman" panose="02020603050405020304" pitchFamily="18" charset="0"/>
+              </a:rPr>
+              <a:t>是否真正使 </a:t>
+            </a:r>
+            <a:r>
+              <a:rPr lang="de-DE" altLang="zh-CN" sz="2400" dirty="0">
+                <a:latin typeface="Times New Roman" panose="02020603050405020304" pitchFamily="18" charset="0"/>
+                <a:ea typeface="SimSun" panose="02010600030101010101" pitchFamily="2" charset="-122"/>
+                <a:cs typeface="Times New Roman" panose="02020603050405020304" pitchFamily="18" charset="0"/>
+              </a:rPr>
+              <a:t>LLM </a:t>
+            </a:r>
+            <a:r>
+              <a:rPr lang="zh-CN" altLang="en-US" sz="2400" dirty="0">
+                <a:latin typeface="Times New Roman" panose="02020603050405020304" pitchFamily="18" charset="0"/>
+                <a:ea typeface="SimSun" panose="02010600030101010101" pitchFamily="2" charset="-122"/>
+                <a:cs typeface="Times New Roman" panose="02020603050405020304" pitchFamily="18" charset="0"/>
+              </a:rPr>
+              <a:t>获得了新的推理能力，还是仅仅利用基础模型中已经存在的推理模式？</a:t>
+            </a:r>
+            <a:endParaRPr lang="en-US" altLang="zh-CN" sz="2400" dirty="0">
+              <a:latin typeface="Times New Roman" panose="02020603050405020304" pitchFamily="18" charset="0"/>
+              <a:ea typeface="SimSun" panose="02010600030101010101" pitchFamily="2" charset="-122"/>
+              <a:cs typeface="Times New Roman" panose="02020603050405020304" pitchFamily="18" charset="0"/>
+            </a:endParaRPr>
+          </a:p>
+          <a:p>
+            <a:endParaRPr lang="en-US" altLang="zh-CN" sz="2400" dirty="0">
+              <a:latin typeface="Times New Roman" panose="02020603050405020304" pitchFamily="18" charset="0"/>
+              <a:ea typeface="SimSun" panose="02010600030101010101" pitchFamily="2" charset="-122"/>
+              <a:cs typeface="Times New Roman" panose="02020603050405020304" pitchFamily="18" charset="0"/>
+            </a:endParaRPr>
+          </a:p>
+          <a:p>
+            <a:r>
+              <a:rPr lang="zh-CN" altLang="en-US" sz="2400" dirty="0">
+                <a:latin typeface="Times New Roman" panose="02020603050405020304" pitchFamily="18" charset="0"/>
+                <a:ea typeface="SimSun" panose="02010600030101010101" pitchFamily="2" charset="-122"/>
+                <a:cs typeface="Times New Roman" panose="02020603050405020304" pitchFamily="18" charset="0"/>
+              </a:rPr>
+              <a:t>动机：没有找到整篇论文的动机</a:t>
+            </a:r>
+            <a:endParaRPr lang="en-US" altLang="zh-CN" sz="2400" dirty="0">
+              <a:latin typeface="Times New Roman" panose="02020603050405020304" pitchFamily="18" charset="0"/>
+              <a:ea typeface="SimSun" panose="02010600030101010101" pitchFamily="2" charset="-122"/>
+              <a:cs typeface="Times New Roman" panose="02020603050405020304" pitchFamily="18" charset="0"/>
+            </a:endParaRPr>
+          </a:p>
+          <a:p>
+            <a:r>
+              <a:rPr lang="en-US" altLang="zh-CN" sz="2400" dirty="0">
+                <a:latin typeface="Times New Roman" panose="02020603050405020304" pitchFamily="18" charset="0"/>
+                <a:ea typeface="SimSun" panose="02010600030101010101" pitchFamily="2" charset="-122"/>
+                <a:cs typeface="Times New Roman" panose="02020603050405020304" pitchFamily="18" charset="0"/>
+              </a:rPr>
+              <a:t>(</a:t>
+            </a:r>
+            <a:r>
+              <a:rPr lang="zh-CN" altLang="en-US" sz="2400" dirty="0">
+                <a:latin typeface="Times New Roman" panose="02020603050405020304" pitchFamily="18" charset="0"/>
+                <a:ea typeface="SimSun" panose="02010600030101010101" pitchFamily="2" charset="-122"/>
+                <a:cs typeface="Times New Roman" panose="02020603050405020304" pitchFamily="18" charset="0"/>
+              </a:rPr>
+              <a:t>注：但是对于具体阶段中每个地方的小动机能看出来</a:t>
+            </a:r>
+            <a:r>
+              <a:rPr lang="en-US" altLang="zh-CN" sz="2400" dirty="0">
+                <a:latin typeface="Times New Roman" panose="02020603050405020304" pitchFamily="18" charset="0"/>
+                <a:ea typeface="SimSun" panose="02010600030101010101" pitchFamily="2" charset="-122"/>
+                <a:cs typeface="Times New Roman" panose="02020603050405020304" pitchFamily="18" charset="0"/>
+              </a:rPr>
+              <a:t>)</a:t>
+            </a:r>
+          </a:p>
+          <a:p>
+            <a:endParaRPr lang="en-US" altLang="zh-CN" sz="2400" dirty="0">
+              <a:latin typeface="Times New Roman" panose="02020603050405020304" pitchFamily="18" charset="0"/>
+              <a:ea typeface="SimSun" panose="02010600030101010101" pitchFamily="2" charset="-122"/>
+              <a:cs typeface="Times New Roman" panose="02020603050405020304" pitchFamily="18" charset="0"/>
+            </a:endParaRPr>
+          </a:p>
+          <a:p>
+            <a:r>
+              <a:rPr lang="zh-CN" altLang="en-US" sz="2400" dirty="0">
+                <a:latin typeface="Times New Roman" panose="02020603050405020304" pitchFamily="18" charset="0"/>
+                <a:ea typeface="SimSun" panose="02010600030101010101" pitchFamily="2" charset="-122"/>
+                <a:cs typeface="Times New Roman" panose="02020603050405020304" pitchFamily="18" charset="0"/>
+              </a:rPr>
+              <a:t>方法：用 </a:t>
+            </a:r>
+            <a:r>
+              <a:rPr lang="de-DE" altLang="zh-CN" sz="2400" dirty="0">
+                <a:latin typeface="Times New Roman" panose="02020603050405020304" pitchFamily="18" charset="0"/>
+                <a:ea typeface="SimSun" panose="02010600030101010101" pitchFamily="2" charset="-122"/>
+                <a:cs typeface="Times New Roman" panose="02020603050405020304" pitchFamily="18" charset="0"/>
+              </a:rPr>
+              <a:t>pass@k </a:t>
+            </a:r>
+            <a:r>
+              <a:rPr lang="zh-CN" altLang="en-US" sz="2400" dirty="0">
+                <a:latin typeface="Times New Roman" panose="02020603050405020304" pitchFamily="18" charset="0"/>
+                <a:ea typeface="SimSun" panose="02010600030101010101" pitchFamily="2" charset="-122"/>
+                <a:cs typeface="Times New Roman" panose="02020603050405020304" pitchFamily="18" charset="0"/>
+              </a:rPr>
+              <a:t>测推理能力，再用 </a:t>
+            </a:r>
+            <a:r>
+              <a:rPr lang="de-DE" altLang="zh-CN" sz="2400" dirty="0">
+                <a:latin typeface="Times New Roman" panose="02020603050405020304" pitchFamily="18" charset="0"/>
+                <a:ea typeface="SimSun" panose="02010600030101010101" pitchFamily="2" charset="-122"/>
+                <a:cs typeface="Times New Roman" panose="02020603050405020304" pitchFamily="18" charset="0"/>
+              </a:rPr>
+              <a:t>coverage/perplexity </a:t>
+            </a:r>
+            <a:r>
+              <a:rPr lang="zh-CN" altLang="en-US" sz="2400" dirty="0">
+                <a:latin typeface="Times New Roman" panose="02020603050405020304" pitchFamily="18" charset="0"/>
+                <a:ea typeface="SimSun" panose="02010600030101010101" pitchFamily="2" charset="-122"/>
+                <a:cs typeface="Times New Roman" panose="02020603050405020304" pitchFamily="18" charset="0"/>
+              </a:rPr>
+              <a:t>判断 </a:t>
+            </a:r>
+            <a:r>
+              <a:rPr lang="de-DE" altLang="zh-CN" sz="2400" dirty="0">
+                <a:latin typeface="Times New Roman" panose="02020603050405020304" pitchFamily="18" charset="0"/>
+                <a:ea typeface="SimSun" panose="02010600030101010101" pitchFamily="2" charset="-122"/>
+                <a:cs typeface="Times New Roman" panose="02020603050405020304" pitchFamily="18" charset="0"/>
+              </a:rPr>
+              <a:t>RLVR </a:t>
+            </a:r>
+            <a:r>
+              <a:rPr lang="zh-CN" altLang="en-US" sz="2400" dirty="0">
+                <a:latin typeface="Times New Roman" panose="02020603050405020304" pitchFamily="18" charset="0"/>
+                <a:ea typeface="SimSun" panose="02010600030101010101" pitchFamily="2" charset="-122"/>
+                <a:cs typeface="Times New Roman" panose="02020603050405020304" pitchFamily="18" charset="0"/>
+              </a:rPr>
+              <a:t>是否产生新的推理路径。</a:t>
+            </a:r>
+            <a:endParaRPr lang="en-US" altLang="zh-CN" sz="2400" dirty="0">
+              <a:latin typeface="Times New Roman" panose="02020603050405020304" pitchFamily="18" charset="0"/>
+              <a:ea typeface="SimSun" panose="02010600030101010101" pitchFamily="2" charset="-122"/>
+              <a:cs typeface="Times New Roman" panose="02020603050405020304" pitchFamily="18" charset="0"/>
+            </a:endParaRPr>
+          </a:p>
+          <a:p>
+            <a:endParaRPr lang="en-US" altLang="zh-CN" sz="2400" dirty="0">
+              <a:latin typeface="Times New Roman" panose="02020603050405020304" pitchFamily="18" charset="0"/>
+              <a:ea typeface="SimSun" panose="02010600030101010101" pitchFamily="2" charset="-122"/>
+              <a:cs typeface="Times New Roman" panose="02020603050405020304" pitchFamily="18" charset="0"/>
+            </a:endParaRPr>
+          </a:p>
+          <a:p>
+            <a:endParaRPr lang="en-US" altLang="zh-CN" sz="2400" dirty="0">
+              <a:latin typeface="Times New Roman" panose="02020603050405020304" pitchFamily="18" charset="0"/>
+              <a:ea typeface="SimSun" panose="02010600030101010101" pitchFamily="2" charset="-122"/>
+              <a:cs typeface="Times New Roman" panose="02020603050405020304" pitchFamily="18" charset="0"/>
+            </a:endParaRPr>
+          </a:p>
+        </p:txBody>
+      </p:sp>
+    </p:spTree>
+    <p:extLst>
+      <p:ext uri="{BB962C8B-B14F-4D97-AF65-F5344CB8AC3E}">
+        <p14:creationId xmlns:p14="http://schemas.microsoft.com/office/powerpoint/2010/main" val="3032947090"/>
+      </p:ext>
+    </p:extLst>
+  </p:cSld>
+  <p:clrMapOvr>
+    <a:masterClrMapping/>
+  </p:clrMapOvr>
+  <p:extLst>
+    <p:ext uri="{6950BFC3-D8DA-4A85-94F7-54DA5524770B}">
+      <p188:commentRel xmlns:p188="http://schemas.microsoft.com/office/powerpoint/2018/8/main" r:id="rId3"/>
+    </p:ext>
+  </p:extLst>
+</p:sld>
+</file>
+
+<file path=ppt/slides/slide15.xml><?xml version="1.0" encoding="utf-8"?>
+<p:sld xmlns:a="http://schemas.openxmlformats.org/drawingml/2006/main" xmlns:r="http://schemas.openxmlformats.org/officeDocument/2006/relationships" xmlns:p="http://schemas.openxmlformats.org/presentationml/2006/main">
+  <p:cSld>
+    <p:spTree>
+      <p:nvGrpSpPr>
+        <p:cNvPr id="1" name="">
+          <a:extLst>
+            <a:ext uri="{FF2B5EF4-FFF2-40B4-BE49-F238E27FC236}">
+              <a16:creationId xmlns:a16="http://schemas.microsoft.com/office/drawing/2014/main" id="{309F7B55-C7D2-9787-0AFB-7C4CA92A7E52}"/>
+            </a:ext>
+          </a:extLst>
+        </p:cNvPr>
+        <p:cNvGrpSpPr/>
+        <p:nvPr/>
+      </p:nvGrpSpPr>
+      <p:grpSpPr>
+        <a:xfrm>
+          <a:off x="0" y="0"/>
+          <a:ext cx="0" cy="0"/>
+          <a:chOff x="0" y="0"/>
+          <a:chExt cx="0" cy="0"/>
+        </a:xfrm>
+      </p:grpSpPr>
+      <p:sp>
+        <p:nvSpPr>
+          <p:cNvPr id="5" name="矩形 4">
+            <a:extLst>
+              <a:ext uri="{FF2B5EF4-FFF2-40B4-BE49-F238E27FC236}">
+                <a16:creationId xmlns:a16="http://schemas.microsoft.com/office/drawing/2014/main" id="{D04C81DE-F268-5630-EA9D-83B1DAE7C7A9}"/>
+              </a:ext>
+            </a:extLst>
+          </p:cNvPr>
+          <p:cNvSpPr/>
+          <p:nvPr/>
+        </p:nvSpPr>
+        <p:spPr>
+          <a:xfrm>
+            <a:off x="19251" y="205583"/>
+            <a:ext cx="12172749" cy="651933"/>
+          </a:xfrm>
+          <a:prstGeom prst="rect">
+            <a:avLst/>
+          </a:prstGeom>
+          <a:solidFill>
+            <a:schemeClr val="bg1"/>
+          </a:solidFill>
+          <a:ln>
+            <a:solidFill>
+              <a:schemeClr val="bg1"/>
+            </a:solidFill>
+          </a:ln>
+        </p:spPr>
+        <p:style>
+          <a:lnRef idx="2">
+            <a:schemeClr val="accent1">
+              <a:shade val="15000"/>
+            </a:schemeClr>
+          </a:lnRef>
+          <a:fillRef idx="1">
+            <a:schemeClr val="accent1"/>
+          </a:fillRef>
+          <a:effectRef idx="0">
+            <a:schemeClr val="accent1"/>
+          </a:effectRef>
+          <a:fontRef idx="minor">
+            <a:schemeClr val="lt1"/>
+          </a:fontRef>
+        </p:style>
+        <p:txBody>
+          <a:bodyPr rtlCol="0" anchor="ctr"/>
+          <a:lstStyle/>
+          <a:p>
+            <a:pPr algn="just" latinLnBrk="1"/>
+            <a:r>
+              <a:rPr lang="zh-CN" altLang="en-US" sz="3000" dirty="0">
+                <a:solidFill>
+                  <a:schemeClr val="tx1"/>
+                </a:solidFill>
+                <a:latin typeface="Times New Roman" panose="02020603050405020304" pitchFamily="18" charset="0"/>
+                <a:ea typeface="SimSun" panose="02010600030101010101" pitchFamily="2" charset="-122"/>
+                <a:cs typeface="Times New Roman" panose="02020603050405020304" pitchFamily="18" charset="0"/>
+              </a:rPr>
+              <a:t>思考</a:t>
+            </a:r>
+            <a:endParaRPr lang="en-US" altLang="zh-CN" sz="3000" dirty="0">
+              <a:solidFill>
+                <a:schemeClr val="tx1"/>
+              </a:solidFill>
+              <a:latin typeface="Times New Roman" panose="02020603050405020304" pitchFamily="18" charset="0"/>
+              <a:ea typeface="SimSun" panose="02010600030101010101" pitchFamily="2" charset="-122"/>
+              <a:cs typeface="Times New Roman" panose="02020603050405020304" pitchFamily="18" charset="0"/>
+            </a:endParaRPr>
+          </a:p>
+        </p:txBody>
+      </p:sp>
+      <p:sp>
+        <p:nvSpPr>
+          <p:cNvPr id="7" name="文本框 6">
+            <a:extLst>
+              <a:ext uri="{FF2B5EF4-FFF2-40B4-BE49-F238E27FC236}">
+                <a16:creationId xmlns:a16="http://schemas.microsoft.com/office/drawing/2014/main" id="{A72C4378-EF71-9119-0FCD-B29A084760F9}"/>
+              </a:ext>
+            </a:extLst>
+          </p:cNvPr>
+          <p:cNvSpPr txBox="1"/>
+          <p:nvPr/>
+        </p:nvSpPr>
+        <p:spPr>
+          <a:xfrm>
+            <a:off x="0" y="948181"/>
+            <a:ext cx="12192000" cy="4154984"/>
+          </a:xfrm>
+          <a:prstGeom prst="rect">
+            <a:avLst/>
+          </a:prstGeom>
+          <a:noFill/>
+        </p:spPr>
+        <p:txBody>
+          <a:bodyPr wrap="square" rtlCol="0">
+            <a:spAutoFit/>
+          </a:bodyPr>
+          <a:lstStyle/>
+          <a:p>
+            <a:r>
+              <a:rPr lang="en-US" altLang="zh-CN" sz="2400" dirty="0">
+                <a:latin typeface="Times New Roman" panose="02020603050405020304" pitchFamily="18" charset="0"/>
+                <a:ea typeface="SimSun" panose="02010600030101010101" pitchFamily="2" charset="-122"/>
+                <a:cs typeface="Times New Roman" panose="02020603050405020304" pitchFamily="18" charset="0"/>
+              </a:rPr>
+              <a:t>1. </a:t>
+            </a:r>
+            <a:r>
+              <a:rPr lang="zh-CN" altLang="en-US" sz="2400" dirty="0">
+                <a:latin typeface="Times New Roman" panose="02020603050405020304" pitchFamily="18" charset="0"/>
+                <a:ea typeface="SimSun" panose="02010600030101010101" pitchFamily="2" charset="-122"/>
+                <a:cs typeface="Times New Roman" panose="02020603050405020304" pitchFamily="18" charset="0"/>
+              </a:rPr>
+              <a:t>我们把</a:t>
+            </a:r>
+            <a:r>
+              <a:rPr lang="de-DE" altLang="zh-CN" sz="2400" dirty="0">
+                <a:latin typeface="Times New Roman" panose="02020603050405020304" pitchFamily="18" charset="0"/>
+                <a:ea typeface="SimSun" panose="02010600030101010101" pitchFamily="2" charset="-122"/>
+                <a:cs typeface="Times New Roman" panose="02020603050405020304" pitchFamily="18" charset="0"/>
+              </a:rPr>
+              <a:t>SPARK</a:t>
+            </a:r>
+            <a:r>
+              <a:rPr lang="zh-CN" altLang="en-US" sz="2400" dirty="0">
+                <a:latin typeface="Times New Roman" panose="02020603050405020304" pitchFamily="18" charset="0"/>
+                <a:ea typeface="SimSun" panose="02010600030101010101" pitchFamily="2" charset="-122"/>
+                <a:cs typeface="Times New Roman" panose="02020603050405020304" pitchFamily="18" charset="0"/>
+              </a:rPr>
+              <a:t>这种方法用于综述中的</a:t>
+            </a:r>
+            <a:r>
+              <a:rPr lang="de-DE" altLang="zh-CN" sz="2400" dirty="0">
+                <a:latin typeface="Times New Roman" panose="02020603050405020304" pitchFamily="18" charset="0"/>
+                <a:ea typeface="SimSun" panose="02010600030101010101" pitchFamily="2" charset="-122"/>
+                <a:cs typeface="Times New Roman" panose="02020603050405020304" pitchFamily="18" charset="0"/>
+              </a:rPr>
+              <a:t>long-horizon decision</a:t>
+            </a:r>
+            <a:r>
+              <a:rPr lang="zh-CN" altLang="en-US" sz="2400" dirty="0">
+                <a:latin typeface="Times New Roman" panose="02020603050405020304" pitchFamily="18" charset="0"/>
+                <a:ea typeface="SimSun" panose="02010600030101010101" pitchFamily="2" charset="-122"/>
+                <a:cs typeface="Times New Roman" panose="02020603050405020304" pitchFamily="18" charset="0"/>
+              </a:rPr>
+              <a:t>问题，能解决吗？</a:t>
+            </a:r>
+            <a:endParaRPr lang="en-US" altLang="zh-CN" sz="2400" dirty="0">
+              <a:latin typeface="Times New Roman" panose="02020603050405020304" pitchFamily="18" charset="0"/>
+              <a:ea typeface="SimSun" panose="02010600030101010101" pitchFamily="2" charset="-122"/>
+              <a:cs typeface="Times New Roman" panose="02020603050405020304" pitchFamily="18" charset="0"/>
+            </a:endParaRPr>
+          </a:p>
+          <a:p>
+            <a:r>
+              <a:rPr lang="zh-CN" altLang="en-US" sz="2400" dirty="0">
+                <a:latin typeface="Times New Roman" panose="02020603050405020304" pitchFamily="18" charset="0"/>
+                <a:ea typeface="SimSun" panose="02010600030101010101" pitchFamily="2" charset="-122"/>
+                <a:cs typeface="Times New Roman" panose="02020603050405020304" pitchFamily="18" charset="0"/>
+              </a:rPr>
+              <a:t>答：可以一定程度上的缓解，因为这种方法主要用于单轮交互的推理中，在多轮交互时还要考虑一些随机动态的状况</a:t>
+            </a:r>
+            <a:r>
+              <a:rPr lang="en-US" altLang="zh-CN" sz="2400" dirty="0">
+                <a:latin typeface="Times New Roman" panose="02020603050405020304" pitchFamily="18" charset="0"/>
+                <a:ea typeface="SimSun" panose="02010600030101010101" pitchFamily="2" charset="-122"/>
+                <a:cs typeface="Times New Roman" panose="02020603050405020304" pitchFamily="18" charset="0"/>
+              </a:rPr>
+              <a:t>(</a:t>
+            </a:r>
+            <a:r>
+              <a:rPr lang="zh-CN" altLang="en-US" sz="2400" dirty="0">
+                <a:latin typeface="Times New Roman" panose="02020603050405020304" pitchFamily="18" charset="0"/>
+                <a:ea typeface="SimSun" panose="02010600030101010101" pitchFamily="2" charset="-122"/>
+                <a:cs typeface="Times New Roman" panose="02020603050405020304" pitchFamily="18" charset="0"/>
+              </a:rPr>
+              <a:t>也就是环境突然反馈了什么</a:t>
+            </a:r>
+            <a:r>
+              <a:rPr lang="en-US" altLang="zh-CN" sz="2400" dirty="0">
+                <a:latin typeface="Times New Roman" panose="02020603050405020304" pitchFamily="18" charset="0"/>
+                <a:ea typeface="SimSun" panose="02010600030101010101" pitchFamily="2" charset="-122"/>
+                <a:cs typeface="Times New Roman" panose="02020603050405020304" pitchFamily="18" charset="0"/>
+              </a:rPr>
+              <a:t>)</a:t>
+            </a:r>
+          </a:p>
+          <a:p>
+            <a:endParaRPr lang="en-US" altLang="zh-CN" sz="2400" dirty="0">
+              <a:latin typeface="Times New Roman" panose="02020603050405020304" pitchFamily="18" charset="0"/>
+              <a:ea typeface="SimSun" panose="02010600030101010101" pitchFamily="2" charset="-122"/>
+              <a:cs typeface="Times New Roman" panose="02020603050405020304" pitchFamily="18" charset="0"/>
+            </a:endParaRPr>
+          </a:p>
+          <a:p>
+            <a:r>
+              <a:rPr lang="en-US" altLang="zh-CN" sz="2400" dirty="0">
+                <a:latin typeface="Times New Roman" panose="02020603050405020304" pitchFamily="18" charset="0"/>
+                <a:ea typeface="SimSun" panose="02010600030101010101" pitchFamily="2" charset="-122"/>
+                <a:cs typeface="Times New Roman" panose="02020603050405020304" pitchFamily="18" charset="0"/>
+              </a:rPr>
+              <a:t>2. RLVR</a:t>
+            </a:r>
+            <a:r>
+              <a:rPr lang="zh-CN" altLang="en-US" sz="2400" dirty="0">
+                <a:latin typeface="Times New Roman" panose="02020603050405020304" pitchFamily="18" charset="0"/>
+                <a:ea typeface="SimSun" panose="02010600030101010101" pitchFamily="2" charset="-122"/>
+                <a:cs typeface="Times New Roman" panose="02020603050405020304" pitchFamily="18" charset="0"/>
+              </a:rPr>
+              <a:t>存在的问题？</a:t>
+            </a:r>
+            <a:endParaRPr lang="en-US" altLang="zh-CN" sz="2400" dirty="0">
+              <a:latin typeface="Times New Roman" panose="02020603050405020304" pitchFamily="18" charset="0"/>
+              <a:ea typeface="SimSun" panose="02010600030101010101" pitchFamily="2" charset="-122"/>
+              <a:cs typeface="Times New Roman" panose="02020603050405020304" pitchFamily="18" charset="0"/>
+            </a:endParaRPr>
+          </a:p>
+          <a:p>
+            <a:r>
+              <a:rPr lang="zh-CN" altLang="en-US" sz="2400" dirty="0">
+                <a:latin typeface="Times New Roman" panose="02020603050405020304" pitchFamily="18" charset="0"/>
+                <a:ea typeface="SimSun" panose="02010600030101010101" pitchFamily="2" charset="-122"/>
+                <a:cs typeface="Times New Roman" panose="02020603050405020304" pitchFamily="18" charset="0"/>
+              </a:rPr>
+              <a:t>答：</a:t>
+            </a:r>
+            <a:r>
+              <a:rPr lang="zh-CN" altLang="en-US" sz="2400" b="1" dirty="0">
+                <a:latin typeface="Times New Roman" panose="02020603050405020304" pitchFamily="18" charset="0"/>
+                <a:ea typeface="SimSun" panose="02010600030101010101" pitchFamily="2" charset="-122"/>
+                <a:cs typeface="Times New Roman" panose="02020603050405020304" pitchFamily="18" charset="0"/>
+              </a:rPr>
+              <a:t>首先，奖励太稀疏，只看最后答案对不对</a:t>
+            </a:r>
+            <a:r>
+              <a:rPr lang="zh-CN" altLang="en-US" sz="2400" dirty="0">
+                <a:latin typeface="Times New Roman" panose="02020603050405020304" pitchFamily="18" charset="0"/>
+                <a:ea typeface="SimSun" panose="02010600030101010101" pitchFamily="2" charset="-122"/>
+                <a:cs typeface="Times New Roman" panose="02020603050405020304" pitchFamily="18" charset="0"/>
+              </a:rPr>
+              <a:t>。如果答案错了，整条推理链都被判负分。但这是不合理的，因为内部的每一个步骤正确性也同样重要。</a:t>
+            </a:r>
+            <a:endParaRPr lang="en-US" altLang="zh-CN" sz="2400" dirty="0">
+              <a:latin typeface="Times New Roman" panose="02020603050405020304" pitchFamily="18" charset="0"/>
+              <a:ea typeface="SimSun" panose="02010600030101010101" pitchFamily="2" charset="-122"/>
+              <a:cs typeface="Times New Roman" panose="02020603050405020304" pitchFamily="18" charset="0"/>
+            </a:endParaRPr>
+          </a:p>
+          <a:p>
+            <a:r>
+              <a:rPr lang="zh-CN" altLang="en-US" sz="2400" b="1" dirty="0">
+                <a:latin typeface="Times New Roman" panose="02020603050405020304" pitchFamily="18" charset="0"/>
+                <a:ea typeface="SimSun" panose="02010600030101010101" pitchFamily="2" charset="-122"/>
+                <a:cs typeface="Times New Roman" panose="02020603050405020304" pitchFamily="18" charset="0"/>
+              </a:rPr>
+              <a:t>其次，当正确解很难被采样到时，</a:t>
+            </a:r>
+            <a:r>
+              <a:rPr lang="en-US" altLang="zh-CN" sz="2400" b="1" dirty="0">
+                <a:latin typeface="Times New Roman" panose="02020603050405020304" pitchFamily="18" charset="0"/>
+                <a:ea typeface="SimSun" panose="02010600030101010101" pitchFamily="2" charset="-122"/>
+                <a:cs typeface="Times New Roman" panose="02020603050405020304" pitchFamily="18" charset="0"/>
+              </a:rPr>
+              <a:t>RLVR</a:t>
+            </a:r>
+            <a:r>
+              <a:rPr lang="zh-CN" altLang="en-US" sz="2400" b="1" dirty="0">
+                <a:latin typeface="Times New Roman" panose="02020603050405020304" pitchFamily="18" charset="0"/>
+                <a:ea typeface="SimSun" panose="02010600030101010101" pitchFamily="2" charset="-122"/>
+                <a:cs typeface="Times New Roman" panose="02020603050405020304" pitchFamily="18" charset="0"/>
+              </a:rPr>
+              <a:t>会失效</a:t>
+            </a:r>
+            <a:r>
+              <a:rPr lang="zh-CN" altLang="en-US" sz="2400" dirty="0">
+                <a:latin typeface="Times New Roman" panose="02020603050405020304" pitchFamily="18" charset="0"/>
+                <a:ea typeface="SimSun" panose="02010600030101010101" pitchFamily="2" charset="-122"/>
+                <a:cs typeface="Times New Roman" panose="02020603050405020304" pitchFamily="18" charset="0"/>
+              </a:rPr>
+              <a:t>。也就是在小模型在难题上经常这样：采样很多次，但全错，</a:t>
+            </a:r>
+            <a:r>
+              <a:rPr lang="en-US" altLang="zh-CN" sz="2400" dirty="0">
+                <a:latin typeface="Times New Roman" panose="02020603050405020304" pitchFamily="18" charset="0"/>
+                <a:ea typeface="SimSun" panose="02010600030101010101" pitchFamily="2" charset="-122"/>
+                <a:cs typeface="Times New Roman" panose="02020603050405020304" pitchFamily="18" charset="0"/>
+              </a:rPr>
+              <a:t>reward </a:t>
+            </a:r>
+            <a:r>
+              <a:rPr lang="zh-CN" altLang="en-US" sz="2400" dirty="0">
+                <a:latin typeface="Times New Roman" panose="02020603050405020304" pitchFamily="18" charset="0"/>
+                <a:ea typeface="SimSun" panose="02010600030101010101" pitchFamily="2" charset="-122"/>
+                <a:cs typeface="Times New Roman" panose="02020603050405020304" pitchFamily="18" charset="0"/>
+              </a:rPr>
+              <a:t>全是</a:t>
+            </a:r>
+            <a:r>
+              <a:rPr lang="en-US" altLang="zh-CN" sz="2400" dirty="0">
+                <a:latin typeface="Times New Roman" panose="02020603050405020304" pitchFamily="18" charset="0"/>
+                <a:ea typeface="SimSun" panose="02010600030101010101" pitchFamily="2" charset="-122"/>
+                <a:cs typeface="Times New Roman" panose="02020603050405020304" pitchFamily="18" charset="0"/>
+              </a:rPr>
+              <a:t>0</a:t>
+            </a:r>
+            <a:r>
+              <a:rPr lang="zh-CN" altLang="en-US" sz="2400" dirty="0">
+                <a:latin typeface="Times New Roman" panose="02020603050405020304" pitchFamily="18" charset="0"/>
+                <a:ea typeface="SimSun" panose="02010600030101010101" pitchFamily="2" charset="-122"/>
+                <a:cs typeface="Times New Roman" panose="02020603050405020304" pitchFamily="18" charset="0"/>
+              </a:rPr>
+              <a:t>，这样</a:t>
+            </a:r>
+            <a:r>
+              <a:rPr lang="en-US" altLang="zh-CN" sz="2400" b="1" dirty="0">
+                <a:latin typeface="Times New Roman" panose="02020603050405020304" pitchFamily="18" charset="0"/>
+                <a:ea typeface="SimSun" panose="02010600030101010101" pitchFamily="2" charset="-122"/>
+                <a:cs typeface="Times New Roman" panose="02020603050405020304" pitchFamily="18" charset="0"/>
+              </a:rPr>
+              <a:t>RLVR</a:t>
+            </a:r>
+            <a:r>
+              <a:rPr lang="zh-CN" altLang="en-US" sz="2400" dirty="0">
+                <a:latin typeface="Times New Roman" panose="02020603050405020304" pitchFamily="18" charset="0"/>
+                <a:ea typeface="SimSun" panose="02010600030101010101" pitchFamily="2" charset="-122"/>
+                <a:cs typeface="Times New Roman" panose="02020603050405020304" pitchFamily="18" charset="0"/>
+              </a:rPr>
+              <a:t>就会失效</a:t>
+            </a:r>
+            <a:r>
+              <a:rPr lang="zh-CN" altLang="en-US" sz="2400" b="1" dirty="0">
+                <a:latin typeface="Times New Roman" panose="02020603050405020304" pitchFamily="18" charset="0"/>
+                <a:ea typeface="SimSun" panose="02010600030101010101" pitchFamily="2" charset="-122"/>
+                <a:cs typeface="Times New Roman" panose="02020603050405020304" pitchFamily="18" charset="0"/>
+              </a:rPr>
+              <a:t>。</a:t>
+            </a:r>
+            <a:endParaRPr lang="en-US" altLang="zh-CN" sz="2400" b="1" dirty="0">
+              <a:latin typeface="Times New Roman" panose="02020603050405020304" pitchFamily="18" charset="0"/>
+              <a:ea typeface="SimSun" panose="02010600030101010101" pitchFamily="2" charset="-122"/>
+              <a:cs typeface="Times New Roman" panose="02020603050405020304" pitchFamily="18" charset="0"/>
+            </a:endParaRPr>
+          </a:p>
+          <a:p>
+            <a:endParaRPr lang="en-US" altLang="zh-CN" sz="2400" dirty="0">
+              <a:latin typeface="Times New Roman" panose="02020603050405020304" pitchFamily="18" charset="0"/>
+              <a:ea typeface="SimSun" panose="02010600030101010101" pitchFamily="2" charset="-122"/>
+              <a:cs typeface="Times New Roman" panose="02020603050405020304" pitchFamily="18" charset="0"/>
+            </a:endParaRPr>
+          </a:p>
+          <a:p>
+            <a:endParaRPr lang="en-US" altLang="zh-CN" sz="2400" dirty="0">
+              <a:latin typeface="Times New Roman" panose="02020603050405020304" pitchFamily="18" charset="0"/>
+              <a:ea typeface="SimSun" panose="02010600030101010101" pitchFamily="2" charset="-122"/>
+              <a:cs typeface="Times New Roman" panose="02020603050405020304" pitchFamily="18" charset="0"/>
+            </a:endParaRPr>
+          </a:p>
+        </p:txBody>
+      </p:sp>
+    </p:spTree>
+    <p:extLst>
+      <p:ext uri="{BB962C8B-B14F-4D97-AF65-F5344CB8AC3E}">
+        <p14:creationId xmlns:p14="http://schemas.microsoft.com/office/powerpoint/2010/main" val="673800897"/>
+      </p:ext>
+    </p:extLst>
+  </p:cSld>
+  <p:clrMapOvr>
+    <a:masterClrMapping/>
+  </p:clrMapOvr>
+</p:sld>
+</file>
+
 <file path=ppt/slides/slide2.xml><?xml version="1.0" encoding="utf-8"?>
 <p:sld xmlns:a="http://schemas.openxmlformats.org/drawingml/2006/main" xmlns:r="http://schemas.openxmlformats.org/officeDocument/2006/relationships" xmlns:p="http://schemas.openxmlformats.org/presentationml/2006/main">
   <p:cSld>
@@ -7072,6 +8048,7 @@
           </a:bodyPr>
           <a:lstStyle/>
           <a:p>
+            <a:pPr algn="just" latinLnBrk="1"/>
             <a:r>
               <a:rPr lang="en-US" altLang="zh-CN" sz="2400" dirty="0">
                 <a:latin typeface="Times New Roman" panose="02020603050405020304" pitchFamily="18" charset="0"/>
@@ -7082,6 +8059,7 @@
             </a:r>
           </a:p>
           <a:p>
+            <a:pPr algn="just" latinLnBrk="1"/>
             <a:r>
               <a:rPr lang="en-US" altLang="zh-CN" sz="2400" dirty="0">
                 <a:latin typeface="Times New Roman" panose="02020603050405020304" pitchFamily="18" charset="0"/>
@@ -7124,6 +8102,7 @@
             </a:r>
           </a:p>
           <a:p>
+            <a:pPr algn="just" latinLnBrk="1"/>
             <a:endParaRPr lang="en-US" altLang="zh-CN" sz="2400" dirty="0">
               <a:latin typeface="Times New Roman" panose="02020603050405020304" pitchFamily="18" charset="0"/>
               <a:ea typeface="SimSun" panose="02010600030101010101" pitchFamily="2" charset="-122"/>
@@ -7131,6 +8110,7 @@
             </a:endParaRPr>
           </a:p>
           <a:p>
+            <a:pPr algn="just" latinLnBrk="1"/>
             <a:r>
               <a:rPr lang="en-US" altLang="zh-CN" sz="2400" dirty="0">
                 <a:latin typeface="Times New Roman" panose="02020603050405020304" pitchFamily="18" charset="0"/>
@@ -7141,6 +8121,7 @@
             </a:r>
           </a:p>
           <a:p>
+            <a:pPr algn="just" latinLnBrk="1"/>
             <a:r>
               <a:rPr lang="en-US" altLang="zh-CN" sz="2400" dirty="0">
                 <a:latin typeface="Times New Roman" panose="02020603050405020304" pitchFamily="18" charset="0"/>
@@ -7151,6 +8132,7 @@
             </a:r>
           </a:p>
           <a:p>
+            <a:pPr algn="just" latinLnBrk="1"/>
             <a:endParaRPr lang="zh-CN" altLang="en-US" sz="2400" dirty="0">
               <a:latin typeface="Times New Roman" panose="02020603050405020304" pitchFamily="18" charset="0"/>
               <a:ea typeface="SimSun" panose="02010600030101010101" pitchFamily="2" charset="-122"/>
@@ -7158,6 +8140,7 @@
             </a:endParaRPr>
           </a:p>
           <a:p>
+            <a:pPr algn="just" latinLnBrk="1"/>
             <a:r>
               <a:rPr lang="en-US" altLang="zh-CN" sz="2400" dirty="0">
                 <a:latin typeface="Times New Roman" panose="02020603050405020304" pitchFamily="18" charset="0"/>
@@ -7168,6 +8151,7 @@
             </a:r>
           </a:p>
           <a:p>
+            <a:pPr algn="just" latinLnBrk="1"/>
             <a:r>
               <a:rPr lang="en-US" altLang="zh-CN" sz="2400" dirty="0">
                 <a:latin typeface="Times New Roman" panose="02020603050405020304" pitchFamily="18" charset="0"/>
@@ -7178,6 +8162,7 @@
             </a:r>
           </a:p>
           <a:p>
+            <a:pPr algn="just" latinLnBrk="1"/>
             <a:endParaRPr lang="en-US" altLang="zh-CN" sz="2400" dirty="0">
               <a:latin typeface="Times New Roman" panose="02020603050405020304" pitchFamily="18" charset="0"/>
               <a:ea typeface="SimSun" panose="02010600030101010101" pitchFamily="2" charset="-122"/>
@@ -7185,6 +8170,7 @@
             </a:endParaRPr>
           </a:p>
           <a:p>
+            <a:pPr algn="just" latinLnBrk="1"/>
             <a:r>
               <a:rPr lang="en-US" altLang="zh-CN" sz="2400" dirty="0">
                 <a:latin typeface="Times New Roman" panose="02020603050405020304" pitchFamily="18" charset="0"/>
@@ -7195,6 +8181,7 @@
             </a:r>
           </a:p>
           <a:p>
+            <a:pPr algn="just" latinLnBrk="1"/>
             <a:endParaRPr lang="en-US" altLang="zh-CN" sz="2400" dirty="0">
               <a:latin typeface="Times New Roman" panose="02020603050405020304" pitchFamily="18" charset="0"/>
               <a:ea typeface="SimSun" panose="02010600030101010101" pitchFamily="2" charset="-122"/>
@@ -7202,104 +8189,14 @@
             </a:endParaRPr>
           </a:p>
           <a:p>
-            <a:r>
-              <a:rPr lang="en-US" altLang="zh-CN" sz="2400" dirty="0">
-                <a:latin typeface="Times New Roman" panose="02020603050405020304" pitchFamily="18" charset="0"/>
-                <a:ea typeface="SimSun" panose="02010600030101010101" pitchFamily="2" charset="-122"/>
-                <a:cs typeface="Times New Roman" panose="02020603050405020304" pitchFamily="18" charset="0"/>
-              </a:rPr>
-              <a:t>(</a:t>
-            </a:r>
-            <a:r>
-              <a:rPr lang="zh-CN" altLang="en-US" sz="2400" dirty="0">
-                <a:solidFill>
-                  <a:srgbClr val="C00000"/>
-                </a:solidFill>
-                <a:latin typeface="Times New Roman" panose="02020603050405020304" pitchFamily="18" charset="0"/>
-                <a:ea typeface="SimSun" panose="02010600030101010101" pitchFamily="2" charset="-122"/>
-                <a:cs typeface="Times New Roman" panose="02020603050405020304" pitchFamily="18" charset="0"/>
-              </a:rPr>
-              <a:t>注：</a:t>
-            </a:r>
-            <a:r>
-              <a:rPr lang="zh-CN" altLang="en-US" sz="2400" dirty="0">
-                <a:latin typeface="Times New Roman" panose="02020603050405020304" pitchFamily="18" charset="0"/>
-                <a:ea typeface="SimSun" panose="02010600030101010101" pitchFamily="2" charset="-122"/>
-                <a:cs typeface="Times New Roman" panose="02020603050405020304" pitchFamily="18" charset="0"/>
-              </a:rPr>
-              <a:t>按照先建立框架，再从推理阶段入手，推理阶段中先建立</a:t>
-            </a:r>
-            <a:r>
-              <a:rPr lang="en-US" altLang="zh-CN" sz="2400" dirty="0">
-                <a:latin typeface="Times New Roman" panose="02020603050405020304" pitchFamily="18" charset="0"/>
-                <a:ea typeface="SimSun" panose="02010600030101010101" pitchFamily="2" charset="-122"/>
-                <a:cs typeface="Times New Roman" panose="02020603050405020304" pitchFamily="18" charset="0"/>
-              </a:rPr>
-              <a:t>PPO</a:t>
-            </a:r>
-            <a:r>
-              <a:rPr lang="zh-CN" altLang="en-US" sz="2400" dirty="0">
-                <a:latin typeface="Times New Roman" panose="02020603050405020304" pitchFamily="18" charset="0"/>
-                <a:ea typeface="SimSun" panose="02010600030101010101" pitchFamily="2" charset="-122"/>
-                <a:cs typeface="Times New Roman" panose="02020603050405020304" pitchFamily="18" charset="0"/>
-              </a:rPr>
-              <a:t>基础知识，再进一步入手</a:t>
-            </a:r>
-            <a:r>
-              <a:rPr lang="en-US" altLang="zh-CN" sz="2400" dirty="0">
-                <a:latin typeface="Times New Roman" panose="02020603050405020304" pitchFamily="18" charset="0"/>
-                <a:ea typeface="SimSun" panose="02010600030101010101" pitchFamily="2" charset="-122"/>
-                <a:cs typeface="Times New Roman" panose="02020603050405020304" pitchFamily="18" charset="0"/>
-              </a:rPr>
-              <a:t>GRPO</a:t>
-            </a:r>
-            <a:r>
-              <a:rPr lang="zh-CN" altLang="en-US" sz="2400" dirty="0">
-                <a:latin typeface="Times New Roman" panose="02020603050405020304" pitchFamily="18" charset="0"/>
-                <a:ea typeface="SimSun" panose="02010600030101010101" pitchFamily="2" charset="-122"/>
-                <a:cs typeface="Times New Roman" panose="02020603050405020304" pitchFamily="18" charset="0"/>
-              </a:rPr>
-              <a:t>，随后关注推理阶段</a:t>
-            </a:r>
-            <a:r>
-              <a:rPr lang="en-US" altLang="zh-CN" sz="2400" dirty="0">
-                <a:latin typeface="Times New Roman" panose="02020603050405020304" pitchFamily="18" charset="0"/>
-                <a:ea typeface="SimSun" panose="02010600030101010101" pitchFamily="2" charset="-122"/>
-                <a:cs typeface="Times New Roman" panose="02020603050405020304" pitchFamily="18" charset="0"/>
-              </a:rPr>
-              <a:t>RL</a:t>
-            </a:r>
-            <a:r>
-              <a:rPr lang="zh-CN" altLang="en-US" sz="2400" dirty="0">
-                <a:latin typeface="Times New Roman" panose="02020603050405020304" pitchFamily="18" charset="0"/>
-                <a:ea typeface="SimSun" panose="02010600030101010101" pitchFamily="2" charset="-122"/>
-                <a:cs typeface="Times New Roman" panose="02020603050405020304" pitchFamily="18" charset="0"/>
-              </a:rPr>
-              <a:t>对</a:t>
-            </a:r>
-            <a:r>
-              <a:rPr lang="en-US" altLang="zh-CN" sz="2400" dirty="0">
-                <a:latin typeface="Times New Roman" panose="02020603050405020304" pitchFamily="18" charset="0"/>
-                <a:ea typeface="SimSun" panose="02010600030101010101" pitchFamily="2" charset="-122"/>
-                <a:cs typeface="Times New Roman" panose="02020603050405020304" pitchFamily="18" charset="0"/>
-              </a:rPr>
-              <a:t>LLM</a:t>
-            </a:r>
-            <a:r>
-              <a:rPr lang="zh-CN" altLang="en-US" sz="2400" dirty="0">
-                <a:latin typeface="Times New Roman" panose="02020603050405020304" pitchFamily="18" charset="0"/>
-                <a:ea typeface="SimSun" panose="02010600030101010101" pitchFamily="2" charset="-122"/>
-                <a:cs typeface="Times New Roman" panose="02020603050405020304" pitchFamily="18" charset="0"/>
-              </a:rPr>
-              <a:t>提升的是什么</a:t>
-            </a:r>
-            <a:r>
-              <a:rPr lang="en-US" altLang="zh-CN" sz="2400" dirty="0">
-                <a:latin typeface="Times New Roman" panose="02020603050405020304" pitchFamily="18" charset="0"/>
-                <a:ea typeface="SimSun" panose="02010600030101010101" pitchFamily="2" charset="-122"/>
-                <a:cs typeface="Times New Roman" panose="02020603050405020304" pitchFamily="18" charset="0"/>
-              </a:rPr>
-              <a:t>)</a:t>
+            <a:pPr algn="just" latinLnBrk="1"/>
+            <a:r>
+              <a:rPr lang="en-US" altLang="zh-CN" sz="2400" dirty="0">
+                <a:latin typeface="Times New Roman" panose="02020603050405020304" pitchFamily="18" charset="0"/>
+                <a:ea typeface="SimSun" panose="02010600030101010101" pitchFamily="2" charset="-122"/>
+                <a:cs typeface="Times New Roman" panose="02020603050405020304" pitchFamily="18" charset="0"/>
+              </a:rPr>
+              <a:t>5. SPARK: STEPWISE PROCESS-AWARE REWARDS FOR REFERENCE-FREE REINFORCEMENT LEARNING</a:t>
             </a:r>
           </a:p>
         </p:txBody>
@@ -8517,7 +9414,21 @@
               </a:rPr>
               <a:t>出了问题。</a:t>
             </a:r>
+            <a:r>
+              <a:rPr lang="zh-CN" altLang="en-US" sz="2400" dirty="0">
+                <a:solidFill>
+                  <a:srgbClr val="FF0000"/>
+                </a:solidFill>
+                <a:latin typeface="Times New Roman" panose="02020603050405020304" pitchFamily="18" charset="0"/>
+                <a:ea typeface="SimSun" panose="02010600030101010101" pitchFamily="2" charset="-122"/>
+                <a:cs typeface="Times New Roman" panose="02020603050405020304" pitchFamily="18" charset="0"/>
+              </a:rPr>
+              <a:t>但实际中我们需要知道到底哪一步有问题</a:t>
+            </a:r>
             <a:endParaRPr lang="en-US" altLang="zh-CN" sz="2400" dirty="0">
+              <a:solidFill>
+                <a:srgbClr val="FF0000"/>
+              </a:solidFill>
               <a:latin typeface="Times New Roman" panose="02020603050405020304" pitchFamily="18" charset="0"/>
               <a:ea typeface="SimSun" panose="02010600030101010101" pitchFamily="2" charset="-122"/>
               <a:cs typeface="Times New Roman" panose="02020603050405020304" pitchFamily="18" charset="0"/>

</xml_diff>